<commit_message>
Update portfolio overview reference E       AssertionError: Output differs from reference: E         Slide 28, Shape 12: Text difference: E             reference: 38% of systems score above market average for Architecture Quality (≥3.5★). E             current:   33% of systems score above market average for Architecture Quality (≥3.5★). E             reference: 31% of systems score market average for Architecture Quality (3★). E             current:   33% of systems score market average for Architecture Quality (3★). E             reference: 31% of systems score below market average for Architecture Quality (≤2.5★). E             current:   33% of systems score below market average for Architecture Quality (≤2.5★). E         Slide 30, Shape 6: Text difference: E             reference: 826 E             current:   821 E       assert False
</commit_message>
<xml_diff>
--- a/tests/report_generator/integration/references/reference_portfolio-overview.pptx
+++ b/tests/report_generator/integration/references/reference_portfolio-overview.pptx
@@ -42184,21 +42184,21 @@
             <a:pPr indent="-283845"/>
             <a:r>
               <a:rPr lang="en-US" dirty="0"/>
-              <a:t>38% of systems score above market average for Architecture Quality (≥3.5★).</a:t>
+              <a:t>33% of systems score above market average for Architecture Quality (≥3.5★).</a:t>
             </a:r>
           </a:p>
           <a:p>
             <a:pPr indent="-283845"/>
             <a:r>
               <a:rPr lang="en-US" dirty="0"/>
-              <a:t>31% of systems score market average for Architecture Quality (3★).</a:t>
+              <a:t>33% of systems score market average for Architecture Quality (3★).</a:t>
             </a:r>
           </a:p>
           <a:p>
             <a:pPr indent="-283845"/>
             <a:r>
               <a:rPr lang="en-US" dirty="0"/>
-              <a:t>31% of systems score below market average for Architecture Quality (≤2.5★).</a:t>
+              <a:t>33% of systems score below market average for Architecture Quality (≤2.5★).</a:t>
             </a:r>
           </a:p>
         </p:txBody>
@@ -43889,7 +43889,7 @@
           <a:p>
             <a:r>
               <a:rPr lang="en-US" b="0" dirty="0"/>
-              <a:t>826</a:t>
+              <a:t>821</a:t>
             </a:r>
           </a:p>
         </p:txBody>

</xml_diff>